<commit_message>
Lead the solution slide with the payer decision, not the build time
"10 min" was the headline outcome, which measures how fast the model was
assembled rather than what a budget impact analysis returns. It reads as a
tooling claim on a slide the audience is reading for a health-economics one.

The outcome card now carries the two things the engine actually produces for a
payer conversation. Affordability: EUR 0.13 per covered member per month, the
same fact as EUR 296.6M over five years but in the unit a payer negotiates on.
And the assumption that decides it: new drug annual price, ranked first of the
ten the tornado moves at +/-20%, which is where evidence spend belongs while
every input is still an estimate.

Build time keeps its claim as supporting point one, next to the reason it is
possible at all.

Co-Authored-By: Claude Opus 5 <noreply@anthropic.com>
Claude-Session: https://claude.ai/code/session_01FEKUe1BU6CkvvDdWkghvhv
</commit_message>
<xml_diff>
--- a/docs/presentation/BIET-Denovo-10min.pptx
+++ b/docs/presentation/BIET-Denovo-10min.pptx
@@ -1144,6 +1144,8 @@
             <a:r>
               <a:rPr lang="en-US" dirty="0"/>
               <a:t>60 seconds. This is the pivot from problem to product.
+Lead with the left card, and lead with the second figure not the first. "A budget impact analysis returns two things. First, what it costs: €296.6 million over five years, which is thirteen cents per covered member per month. Quote both, in that order, because the second is the unit the payer negotiates on."
+Then the lower half, which is the part that matters for an early-stage asset: "Second, it tells you which assumption the answer actually turns on. Here it is the new drug's annual price, ranked first of ten. That is where the next evidence spend goes." At this stage every input is an estimate, so knowing which estimate to go and firm up is worth more than the point figure.
 "BIET turns population data into a five-year payer forecast in a single sitting, with the scenarios, the sensitivity and the audit trail attached."
 Take the three points in order, one sentence each. Point 1 is the engineering decision that makes the demo work. Point 3 is the one that makes the answer defensible.
 Do not oversell. The claim is 10 minutes to a defensible early-stage estimate, not a validated HTA submission.</a:t>
@@ -7555,11 +7557,11 @@
         <p:spPr>
           <a:xfrm>
             <a:off x="566928" y="2194560"/>
-            <a:ext cx="4114800" cy="3218688"/>
+            <a:ext cx="4114800" cy="3639312"/>
           </a:xfrm>
           <a:prstGeom prst="roundRect">
             <a:avLst>
-              <a:gd name="adj" fmla="val 1705"/>
+              <a:gd name="adj" fmla="val 1508"/>
             </a:avLst>
           </a:prstGeom>
           <a:solidFill>
@@ -7583,7 +7585,7 @@
         </p:nvSpPr>
         <p:spPr>
           <a:xfrm>
-            <a:off x="950976" y="2523744"/>
+            <a:off x="950976" y="2450592"/>
             <a:ext cx="3383280" cy="237744"/>
           </a:xfrm>
           <a:prstGeom prst="rect">
@@ -7608,7 +7610,7 @@
                 <a:ea typeface="Times New Roman" pitchFamily="34" charset="-122"/>
                 <a:cs typeface="Times New Roman" pitchFamily="34" charset="-120"/>
               </a:rPr>
-              <a:t>HEADLINE OUTCOME</a:t>
+              <a:t>AFFORDABILITY</a:t>
             </a:r>
             <a:endParaRPr lang="en-US" sz="1100" dirty="0"/>
           </a:p>
@@ -7622,24 +7624,24 @@
         </p:nvSpPr>
         <p:spPr>
           <a:xfrm>
-            <a:off x="914400" y="2944368"/>
-            <a:ext cx="3474720" cy="914400"/>
-          </a:xfrm>
-          <a:prstGeom prst="rect">
-            <a:avLst/>
-          </a:prstGeom>
-          <a:noFill/>
-          <a:ln/>
-        </p:spPr>
-        <p:txBody>
-          <a:bodyPr wrap="square" lIns="0" tIns="0" rIns="0" bIns="0" rtlCol="0" anchor="ctr"/>
-          <a:lstStyle/>
-          <a:p>
-            <a:pPr indent="0" marL="0">
-              <a:buNone/>
-            </a:pPr>
-            <a:r>
-              <a:rPr lang="en-US" sz="6200" b="1" dirty="0">
+            <a:off x="914400" y="2706624"/>
+            <a:ext cx="3474720" cy="731520"/>
+          </a:xfrm>
+          <a:prstGeom prst="rect">
+            <a:avLst/>
+          </a:prstGeom>
+          <a:noFill/>
+          <a:ln/>
+        </p:spPr>
+        <p:txBody>
+          <a:bodyPr wrap="square" lIns="0" tIns="0" rIns="0" bIns="0" rtlCol="0" anchor="ctr"/>
+          <a:lstStyle/>
+          <a:p>
+            <a:pPr indent="0" marL="0">
+              <a:buNone/>
+            </a:pPr>
+            <a:r>
+              <a:rPr lang="en-US" sz="4600" b="1" dirty="0">
                 <a:solidFill>
                   <a:srgbClr val="FFFFFF"/>
                 </a:solidFill>
@@ -7647,9 +7649,9 @@
                 <a:ea typeface="Times New Roman" pitchFamily="34" charset="-122"/>
                 <a:cs typeface="Times New Roman" pitchFamily="34" charset="-120"/>
               </a:rPr>
-              <a:t>10 min</a:t>
-            </a:r>
-            <a:endParaRPr lang="en-US" sz="6200" dirty="0"/>
+              <a:t>€0.13</a:t>
+            </a:r>
+            <a:endParaRPr lang="en-US" sz="4600" dirty="0"/>
           </a:p>
         </p:txBody>
       </p:sp>
@@ -7661,27 +7663,27 @@
         </p:nvSpPr>
         <p:spPr>
           <a:xfrm>
-            <a:off x="950976" y="4041648"/>
-            <a:ext cx="3383280" cy="1005840"/>
-          </a:xfrm>
-          <a:prstGeom prst="rect">
-            <a:avLst/>
-          </a:prstGeom>
-          <a:noFill/>
-          <a:ln/>
-        </p:spPr>
-        <p:txBody>
-          <a:bodyPr wrap="square" lIns="0" tIns="0" rIns="0" bIns="0" rtlCol="0" anchor="ctr"/>
+            <a:off x="950976" y="3511296"/>
+            <a:ext cx="3383280" cy="822960"/>
+          </a:xfrm>
+          <a:prstGeom prst="rect">
+            <a:avLst/>
+          </a:prstGeom>
+          <a:noFill/>
+          <a:ln/>
+        </p:spPr>
+        <p:txBody>
+          <a:bodyPr wrap="square" lIns="0" tIns="0" rIns="0" bIns="0" rtlCol="0" anchor="t"/>
           <a:lstStyle/>
           <a:p>
             <a:pPr indent="0" marL="0">
               <a:lnSpc>
-                <a:spcPct val="112000"/>
+                <a:spcPct val="110000"/>
               </a:lnSpc>
               <a:buNone/>
             </a:pPr>
             <a:r>
-              <a:rPr lang="en-US" sz="1400" dirty="0">
+              <a:rPr lang="en-US" sz="1300" dirty="0">
                 <a:solidFill>
                   <a:srgbClr val="E4DFFC"/>
                 </a:solidFill>
@@ -7689,15 +7691,135 @@
                 <a:ea typeface="Times New Roman" pitchFamily="34" charset="-122"/>
                 <a:cs typeface="Times New Roman" pitchFamily="34" charset="-120"/>
               </a:rPr>
-              <a:t>to build a five-year model and stress-test it, against weeks of bespoke spreadsheet work.</a:t>
-            </a:r>
-            <a:endParaRPr lang="en-US" sz="1400" dirty="0"/>
-          </a:p>
-        </p:txBody>
-      </p:sp>
-      <p:sp>
-        <p:nvSpPr>
-          <p:cNvPr id="9" name="Shape 7"/>
+              <a:t>per covered member per month. The same fact as €296.6M over five years, in the unit a payer negotiates on.</a:t>
+            </a:r>
+            <a:endParaRPr lang="en-US" sz="1300" dirty="0"/>
+          </a:p>
+        </p:txBody>
+      </p:sp>
+      <p:sp>
+        <p:nvSpPr>
+          <p:cNvPr id="9" name="Text 7"/>
+          <p:cNvSpPr txBox="1"/>
+          <p:nvPr/>
+        </p:nvSpPr>
+        <p:spPr>
+          <a:xfrm>
+            <a:off x="950976" y="4480560"/>
+            <a:ext cx="3383280" cy="237744"/>
+          </a:xfrm>
+          <a:prstGeom prst="rect">
+            <a:avLst/>
+          </a:prstGeom>
+          <a:noFill/>
+          <a:ln/>
+        </p:spPr>
+        <p:txBody>
+          <a:bodyPr wrap="square" lIns="0" tIns="0" rIns="0" bIns="0" rtlCol="0" anchor="ctr"/>
+          <a:lstStyle/>
+          <a:p>
+            <a:pPr indent="0" marL="0">
+              <a:buNone/>
+            </a:pPr>
+            <a:r>
+              <a:rPr lang="en-US" sz="1100" b="1" spc="200" kern="0" dirty="0">
+                <a:solidFill>
+                  <a:srgbClr val="D9D2FA"/>
+                </a:solidFill>
+                <a:latin typeface="Times New Roman" pitchFamily="34" charset="0"/>
+                <a:ea typeface="Times New Roman" pitchFamily="34" charset="-122"/>
+                <a:cs typeface="Times New Roman" pitchFamily="34" charset="-120"/>
+              </a:rPr>
+              <a:t>WHAT DECIDES IT</a:t>
+            </a:r>
+            <a:endParaRPr lang="en-US" sz="1100" dirty="0"/>
+          </a:p>
+        </p:txBody>
+      </p:sp>
+      <p:sp>
+        <p:nvSpPr>
+          <p:cNvPr id="10" name="Text 8"/>
+          <p:cNvSpPr txBox="1"/>
+          <p:nvPr/>
+        </p:nvSpPr>
+        <p:spPr>
+          <a:xfrm>
+            <a:off x="932688" y="4736592"/>
+            <a:ext cx="3474720" cy="310896"/>
+          </a:xfrm>
+          <a:prstGeom prst="rect">
+            <a:avLst/>
+          </a:prstGeom>
+          <a:noFill/>
+          <a:ln/>
+        </p:spPr>
+        <p:txBody>
+          <a:bodyPr wrap="square" lIns="0" tIns="0" rIns="0" bIns="0" rtlCol="0" anchor="ctr"/>
+          <a:lstStyle/>
+          <a:p>
+            <a:pPr indent="0" marL="0">
+              <a:buNone/>
+            </a:pPr>
+            <a:r>
+              <a:rPr lang="en-US" sz="2000" b="1" dirty="0">
+                <a:solidFill>
+                  <a:srgbClr val="FFFFFF"/>
+                </a:solidFill>
+                <a:latin typeface="Times New Roman" pitchFamily="34" charset="0"/>
+                <a:ea typeface="Times New Roman" pitchFamily="34" charset="-122"/>
+                <a:cs typeface="Times New Roman" pitchFamily="34" charset="-120"/>
+              </a:rPr>
+              <a:t>New drug annual price</a:t>
+            </a:r>
+            <a:endParaRPr lang="en-US" sz="2000" dirty="0"/>
+          </a:p>
+        </p:txBody>
+      </p:sp>
+      <p:sp>
+        <p:nvSpPr>
+          <p:cNvPr id="11" name="Text 9"/>
+          <p:cNvSpPr txBox="1"/>
+          <p:nvPr/>
+        </p:nvSpPr>
+        <p:spPr>
+          <a:xfrm>
+            <a:off x="950976" y="5084064"/>
+            <a:ext cx="3383280" cy="694944"/>
+          </a:xfrm>
+          <a:prstGeom prst="rect">
+            <a:avLst/>
+          </a:prstGeom>
+          <a:noFill/>
+          <a:ln/>
+        </p:spPr>
+        <p:txBody>
+          <a:bodyPr wrap="square" lIns="0" tIns="0" rIns="0" bIns="0" rtlCol="0" anchor="t"/>
+          <a:lstStyle/>
+          <a:p>
+            <a:pPr indent="0" marL="0">
+              <a:lnSpc>
+                <a:spcPct val="110000"/>
+              </a:lnSpc>
+              <a:buNone/>
+            </a:pPr>
+            <a:r>
+              <a:rPr lang="en-US" sz="1300" dirty="0">
+                <a:solidFill>
+                  <a:srgbClr val="E4DFFC"/>
+                </a:solidFill>
+                <a:latin typeface="Times New Roman" pitchFamily="34" charset="0"/>
+                <a:ea typeface="Times New Roman" pitchFamily="34" charset="-122"/>
+                <a:cs typeface="Times New Roman" pitchFamily="34" charset="-120"/>
+              </a:rPr>
+              <a:t>Ranked first of ten assumptions, each moved ±20%. Evidence spend goes where it changes the answer.</a:t>
+            </a:r>
+            <a:endParaRPr lang="en-US" sz="1300" dirty="0"/>
+          </a:p>
+        </p:txBody>
+      </p:sp>
+      <p:sp>
+        <p:nvSpPr>
+          <p:cNvPr id="12" name="Shape 10"/>
           <p:cNvSpPr/>
           <p:nvPr/>
         </p:nvSpPr>
@@ -7719,7 +7841,7 @@
       </p:sp>
       <p:sp>
         <p:nvSpPr>
-          <p:cNvPr id="10" name="Text 8"/>
+          <p:cNvPr id="13" name="Text 11"/>
           <p:cNvSpPr txBox="1"/>
           <p:nvPr/>
         </p:nvSpPr>
@@ -7758,7 +7880,7 @@
       </p:sp>
       <p:sp>
         <p:nvSpPr>
-          <p:cNvPr id="11" name="Text 9"/>
+          <p:cNvPr id="14" name="Text 12"/>
           <p:cNvSpPr txBox="1"/>
           <p:nvPr/>
         </p:nvSpPr>
@@ -7797,7 +7919,7 @@
       </p:sp>
       <p:sp>
         <p:nvSpPr>
-          <p:cNvPr id="12" name="Text 10"/>
+          <p:cNvPr id="15" name="Text 13"/>
           <p:cNvSpPr txBox="1"/>
           <p:nvPr/>
         </p:nvSpPr>
@@ -7831,7 +7953,7 @@
                 <a:ea typeface="Times New Roman" pitchFamily="34" charset="-122"/>
                 <a:cs typeface="Times New Roman" pitchFamily="34" charset="-120"/>
               </a:rPr>
-              <a:t>No network call sits between an input and its result, so sensitivity is something you feel rather than a job you queue.</a:t>
+              <a:t>No network call sits between an input and its result. A five-year model takes minutes to build and seconds to re-run, against weeks of spreadsheet work.</a:t>
             </a:r>
             <a:endParaRPr lang="en-US" sz="1300" dirty="0"/>
           </a:p>
@@ -7839,7 +7961,7 @@
       </p:sp>
       <p:sp>
         <p:nvSpPr>
-          <p:cNvPr id="13" name="Shape 11"/>
+          <p:cNvPr id="16" name="Shape 14"/>
           <p:cNvSpPr/>
           <p:nvPr/>
         </p:nvSpPr>
@@ -7861,7 +7983,7 @@
       </p:sp>
       <p:sp>
         <p:nvSpPr>
-          <p:cNvPr id="14" name="Text 12"/>
+          <p:cNvPr id="17" name="Text 15"/>
           <p:cNvSpPr txBox="1"/>
           <p:nvPr/>
         </p:nvSpPr>
@@ -7900,7 +8022,7 @@
       </p:sp>
       <p:sp>
         <p:nvSpPr>
-          <p:cNvPr id="15" name="Text 13"/>
+          <p:cNvPr id="18" name="Text 16"/>
           <p:cNvSpPr txBox="1"/>
           <p:nvPr/>
         </p:nvSpPr>
@@ -7939,7 +8061,7 @@
       </p:sp>
       <p:sp>
         <p:nvSpPr>
-          <p:cNvPr id="16" name="Text 14"/>
+          <p:cNvPr id="19" name="Text 17"/>
           <p:cNvSpPr txBox="1"/>
           <p:nvPr/>
         </p:nvSpPr>
@@ -7981,7 +8103,7 @@
       </p:sp>
       <p:sp>
         <p:nvSpPr>
-          <p:cNvPr id="17" name="Shape 15"/>
+          <p:cNvPr id="20" name="Shape 18"/>
           <p:cNvSpPr/>
           <p:nvPr/>
         </p:nvSpPr>
@@ -8003,7 +8125,7 @@
       </p:sp>
       <p:sp>
         <p:nvSpPr>
-          <p:cNvPr id="18" name="Text 16"/>
+          <p:cNvPr id="21" name="Text 19"/>
           <p:cNvSpPr txBox="1"/>
           <p:nvPr/>
         </p:nvSpPr>
@@ -8042,7 +8164,7 @@
       </p:sp>
       <p:sp>
         <p:nvSpPr>
-          <p:cNvPr id="19" name="Text 17"/>
+          <p:cNvPr id="22" name="Text 20"/>
           <p:cNvSpPr txBox="1"/>
           <p:nvPr/>
         </p:nvSpPr>
@@ -8081,7 +8203,7 @@
       </p:sp>
       <p:sp>
         <p:nvSpPr>
-          <p:cNvPr id="20" name="Text 18"/>
+          <p:cNvPr id="23" name="Text 21"/>
           <p:cNvSpPr txBox="1"/>
           <p:nvPr/>
         </p:nvSpPr>
@@ -8123,7 +8245,7 @@
       </p:sp>
       <p:sp>
         <p:nvSpPr>
-          <p:cNvPr id="22" name="Text 19"/>
+          <p:cNvPr id="25" name="Text 22"/>
           <p:cNvSpPr txBox="1"/>
           <p:nvPr/>
         </p:nvSpPr>
@@ -8162,7 +8284,7 @@
       </p:sp>
       <p:sp>
         <p:nvSpPr>
-          <p:cNvPr id="23" name="Text 20"/>
+          <p:cNvPr id="26" name="Text 23"/>
           <p:cNvSpPr txBox="1"/>
           <p:nvPr/>
         </p:nvSpPr>

</xml_diff>

<commit_message>
Drop the slot and round line from the title slide
The bottom-right line read "10-minute presentation - Round 2". Both facts
belong to one sitting of one event, so they date the deck the moment it is
reused, and neither tells the audience anything they do not already know from
being in the room. The live URL keeps the corner on its own.

Co-Authored-By: Claude Opus 5 <noreply@anthropic.com>
Claude-Session: https://claude.ai/code/session_01FEKUe1BU6CkvvDdWkghvhv
</commit_message>
<xml_diff>
--- a/docs/presentation/BIET-Denovo-10min.pptx
+++ b/docs/presentation/BIET-Denovo-10min.pptx
@@ -2652,45 +2652,6 @@
           </a:p>
         </p:txBody>
       </p:sp>
-      <p:sp>
-        <p:nvSpPr>
-          <p:cNvPr id="17" name="Text 15"/>
-          <p:cNvSpPr txBox="1"/>
-          <p:nvPr/>
-        </p:nvSpPr>
-        <p:spPr>
-          <a:xfrm>
-            <a:off x="7052767" y="5989320"/>
-            <a:ext cx="4572000" cy="274320"/>
-          </a:xfrm>
-          <a:prstGeom prst="rect">
-            <a:avLst/>
-          </a:prstGeom>
-          <a:noFill/>
-          <a:ln/>
-        </p:spPr>
-        <p:txBody>
-          <a:bodyPr wrap="square" lIns="0" tIns="0" rIns="0" bIns="0" rtlCol="0" anchor="ctr"/>
-          <a:lstStyle/>
-          <a:p>
-            <a:pPr algn="r" indent="0" marL="0">
-              <a:buNone/>
-            </a:pPr>
-            <a:r>
-              <a:rPr lang="en-US" sz="1300" dirty="0">
-                <a:solidFill>
-                  <a:srgbClr val="B9B3E8"/>
-                </a:solidFill>
-                <a:latin typeface="Times New Roman" pitchFamily="34" charset="0"/>
-                <a:ea typeface="Times New Roman" pitchFamily="34" charset="-122"/>
-                <a:cs typeface="Times New Roman" pitchFamily="34" charset="-120"/>
-              </a:rPr>
-              <a:t>10-minute presentation  ·  Round 2</a:t>
-            </a:r>
-            <a:endParaRPr lang="en-US" sz="1300" dirty="0"/>
-          </a:p>
-        </p:txBody>
-      </p:sp>
     </p:spTree>
   </p:cSld>
   <p:clrMapOvr>

</xml_diff>

<commit_message>
Correct two team roles, order the cards, and size the avatars for photographs
Nilesh owns the evidence module and Sumithra the backend and database; both
were assigned to other people when the roles were inferred from the repository
alone. The remaining three titles are still an inference and the speaker notes
now say which two are confirmed and which three to check.

Cards run alphabetically by first name rather than in the order the
workstreams happened to be listed, so the slide does not read as a ranking.

Avatars go from 0.86 to 1.3 inches so a face is legible from the back of a
call, with the card grown to match. The circle is a plain shape under a
separate initials text box, so a photograph goes in as a picture fill with the
initials deleted; the notes carry that instruction.

Co-Authored-By: Claude Opus 5 <noreply@anthropic.com>
Claude-Session: https://claude.ai/code/session_01FEKUe1BU6CkvvDdWkghvhv
</commit_message>
<xml_diff>
--- a/docs/presentation/BIET-Denovo-10min.pptx
+++ b/docs/presentation/BIET-Denovo-10min.pptx
@@ -1606,7 +1606,9 @@
             <a:r>
               <a:rPr lang="en-US" dirty="0"/>
               <a:t>30 seconds, and no longer. Names and one workstream each.
-CHECK THE ROLES BEFORE YOU PRESENT. They were assigned from the workstreams visible in the repository, not from who actually did what. Swap them so each person owns what they can answer questions about in Q&amp;A, because that is the only reason this slide is here.
+Cards run alphabetically by first name, so nobody reads as ranked above anyone else.
+Two of the five are confirmed: Nilesh owns the evidence module, Sumithra owns the backend and the database. The other three titles were split across the remaining workstreams in the repository rather than from who actually did what, so check them. Each person should own the area they can answer questions about, because that is the only reason this slide is here.
+To drop in photographs: click a circle, Format Shape, Fill, Picture, then delete the initials text box sitting over it.
 If everyone is on camera, let each person say their own name and line. It is faster than one person reading five cards, and it puts a face against the workstream the judges may want to question.</a:t>
             </a:r>
             <a:endParaRPr lang="en-US" dirty="0"/>
@@ -13198,12 +13200,12 @@
         </p:nvSpPr>
         <p:spPr>
           <a:xfrm>
-            <a:off x="566928" y="2286000"/>
-            <a:ext cx="2006742" cy="3127248"/>
+            <a:off x="566928" y="2231136"/>
+            <a:ext cx="1992112" cy="3639312"/>
           </a:xfrm>
           <a:prstGeom prst="roundRect">
             <a:avLst>
-              <a:gd name="adj" fmla="val 2734"/>
+              <a:gd name="adj" fmla="val 2754"/>
             </a:avLst>
           </a:prstGeom>
           <a:solidFill>
@@ -13227,8 +13229,8 @@
         </p:nvSpPr>
         <p:spPr>
           <a:xfrm>
-            <a:off x="1177107" y="2615184"/>
-            <a:ext cx="786384" cy="786384"/>
+            <a:off x="968624" y="2560320"/>
+            <a:ext cx="1188720" cy="1188720"/>
           </a:xfrm>
           <a:prstGeom prst="roundRect">
             <a:avLst>
@@ -13249,8 +13251,8 @@
         </p:nvSpPr>
         <p:spPr>
           <a:xfrm>
-            <a:off x="1177107" y="2615184"/>
-            <a:ext cx="786384" cy="786384"/>
+            <a:off x="968624" y="2560320"/>
+            <a:ext cx="1188720" cy="1188720"/>
           </a:xfrm>
           <a:prstGeom prst="rect">
             <a:avLst/>
@@ -13266,7 +13268,7 @@
               <a:buNone/>
             </a:pPr>
             <a:r>
-              <a:rPr lang="en-US" sz="2200" b="1" dirty="0">
+              <a:rPr lang="en-US" sz="3000" b="1" dirty="0">
                 <a:solidFill>
                   <a:srgbClr val="FFFFFF"/>
                 </a:solidFill>
@@ -13274,9 +13276,9 @@
                 <a:ea typeface="Times New Roman" pitchFamily="34" charset="-122"/>
                 <a:cs typeface="Times New Roman" pitchFamily="34" charset="-120"/>
               </a:rPr>
-              <a:t>SR</a:t>
-            </a:r>
-            <a:endParaRPr lang="en-US" sz="2200" dirty="0"/>
+              <a:t>AK</a:t>
+            </a:r>
+            <a:endParaRPr lang="en-US" sz="3000" dirty="0"/>
           </a:p>
         </p:txBody>
       </p:sp>
@@ -13288,8 +13290,8 @@
         </p:nvSpPr>
         <p:spPr>
           <a:xfrm>
-            <a:off x="749808" y="3602736"/>
-            <a:ext cx="1640982" cy="512064"/>
+            <a:off x="713232" y="3950208"/>
+            <a:ext cx="1699504" cy="310896"/>
           </a:xfrm>
           <a:prstGeom prst="rect">
             <a:avLst/>
@@ -13302,9 +13304,6 @@
           <a:lstStyle/>
           <a:p>
             <a:pPr algn="ctr" indent="0" marL="0">
-              <a:lnSpc>
-                <a:spcPct val="100000"/>
-              </a:lnSpc>
               <a:buNone/>
             </a:pPr>
             <a:r>
@@ -13316,7 +13315,7 @@
                 <a:ea typeface="Times New Roman" pitchFamily="34" charset="-122"/>
                 <a:cs typeface="Times New Roman" pitchFamily="34" charset="-120"/>
               </a:rPr>
-              <a:t>Sumithra Raju</a:t>
+              <a:t>Atharva Kadam</a:t>
             </a:r>
             <a:endParaRPr lang="en-US" sz="1500" dirty="0"/>
           </a:p>
@@ -13330,17 +13329,17 @@
         </p:nvSpPr>
         <p:spPr>
           <a:xfrm>
-            <a:off x="731520" y="4114800"/>
-            <a:ext cx="1677558" cy="420624"/>
-          </a:xfrm>
-          <a:prstGeom prst="rect">
-            <a:avLst/>
-          </a:prstGeom>
-          <a:noFill/>
-          <a:ln/>
-        </p:spPr>
-        <p:txBody>
-          <a:bodyPr wrap="square" lIns="0" tIns="0" rIns="0" bIns="0" rtlCol="0" anchor="ctr"/>
+            <a:off x="694944" y="4315968"/>
+            <a:ext cx="1736080" cy="457200"/>
+          </a:xfrm>
+          <a:prstGeom prst="rect">
+            <a:avLst/>
+          </a:prstGeom>
+          <a:noFill/>
+          <a:ln/>
+        </p:spPr>
+        <p:txBody>
+          <a:bodyPr wrap="square" lIns="0" tIns="0" rIns="0" bIns="0" rtlCol="0" anchor="t"/>
           <a:lstStyle/>
           <a:p>
             <a:pPr algn="ctr" indent="0" marL="0">
@@ -13372,17 +13371,17 @@
         </p:nvSpPr>
         <p:spPr>
           <a:xfrm>
-            <a:off x="768096" y="4590288"/>
-            <a:ext cx="1604406" cy="713232"/>
-          </a:xfrm>
-          <a:prstGeom prst="rect">
-            <a:avLst/>
-          </a:prstGeom>
-          <a:noFill/>
-          <a:ln/>
-        </p:spPr>
-        <p:txBody>
-          <a:bodyPr wrap="square" lIns="0" tIns="0" rIns="0" bIns="0" rtlCol="0" anchor="ctr"/>
+            <a:off x="713232" y="4864608"/>
+            <a:ext cx="1699504" cy="841248"/>
+          </a:xfrm>
+          <a:prstGeom prst="rect">
+            <a:avLst/>
+          </a:prstGeom>
+          <a:noFill/>
+          <a:ln/>
+        </p:spPr>
+        <p:txBody>
+          <a:bodyPr wrap="square" lIns="0" tIns="0" rIns="0" bIns="0" rtlCol="0" anchor="t"/>
           <a:lstStyle/>
           <a:p>
             <a:pPr algn="ctr" indent="0" marL="0">
@@ -13414,12 +13413,12 @@
         </p:nvSpPr>
         <p:spPr>
           <a:xfrm>
-            <a:off x="2829702" y="2286000"/>
-            <a:ext cx="2006742" cy="3127248"/>
+            <a:off x="2833360" y="2231136"/>
+            <a:ext cx="1992112" cy="3639312"/>
           </a:xfrm>
           <a:prstGeom prst="roundRect">
             <a:avLst>
-              <a:gd name="adj" fmla="val 2734"/>
+              <a:gd name="adj" fmla="val 2754"/>
             </a:avLst>
           </a:prstGeom>
           <a:solidFill>
@@ -13443,8 +13442,8 @@
         </p:nvSpPr>
         <p:spPr>
           <a:xfrm>
-            <a:off x="3439881" y="2615184"/>
-            <a:ext cx="786384" cy="786384"/>
+            <a:off x="3235056" y="2560320"/>
+            <a:ext cx="1188720" cy="1188720"/>
           </a:xfrm>
           <a:prstGeom prst="roundRect">
             <a:avLst>
@@ -13465,8 +13464,8 @@
         </p:nvSpPr>
         <p:spPr>
           <a:xfrm>
-            <a:off x="3439881" y="2615184"/>
-            <a:ext cx="786384" cy="786384"/>
+            <a:off x="3235056" y="2560320"/>
+            <a:ext cx="1188720" cy="1188720"/>
           </a:xfrm>
           <a:prstGeom prst="rect">
             <a:avLst/>
@@ -13482,7 +13481,7 @@
               <a:buNone/>
             </a:pPr>
             <a:r>
-              <a:rPr lang="en-US" sz="2200" b="1" dirty="0">
+              <a:rPr lang="en-US" sz="3000" b="1" dirty="0">
                 <a:solidFill>
                   <a:srgbClr val="FFFFFF"/>
                 </a:solidFill>
@@ -13492,7 +13491,7 @@
               </a:rPr>
               <a:t>NA</a:t>
             </a:r>
-            <a:endParaRPr lang="en-US" sz="2200" dirty="0"/>
+            <a:endParaRPr lang="en-US" sz="3000" dirty="0"/>
           </a:p>
         </p:txBody>
       </p:sp>
@@ -13504,8 +13503,8 @@
         </p:nvSpPr>
         <p:spPr>
           <a:xfrm>
-            <a:off x="3012582" y="3602736"/>
-            <a:ext cx="1640982" cy="512064"/>
+            <a:off x="2979664" y="3950208"/>
+            <a:ext cx="1699504" cy="310896"/>
           </a:xfrm>
           <a:prstGeom prst="rect">
             <a:avLst/>
@@ -13518,9 +13517,6 @@
           <a:lstStyle/>
           <a:p>
             <a:pPr algn="ctr" indent="0" marL="0">
-              <a:lnSpc>
-                <a:spcPct val="100000"/>
-              </a:lnSpc>
               <a:buNone/>
             </a:pPr>
             <a:r>
@@ -13546,17 +13542,17 @@
         </p:nvSpPr>
         <p:spPr>
           <a:xfrm>
-            <a:off x="2994294" y="4114800"/>
-            <a:ext cx="1677558" cy="420624"/>
-          </a:xfrm>
-          <a:prstGeom prst="rect">
-            <a:avLst/>
-          </a:prstGeom>
-          <a:noFill/>
-          <a:ln/>
-        </p:spPr>
-        <p:txBody>
-          <a:bodyPr wrap="square" lIns="0" tIns="0" rIns="0" bIns="0" rtlCol="0" anchor="ctr"/>
+            <a:off x="2961376" y="4315968"/>
+            <a:ext cx="1736080" cy="457200"/>
+          </a:xfrm>
+          <a:prstGeom prst="rect">
+            <a:avLst/>
+          </a:prstGeom>
+          <a:noFill/>
+          <a:ln/>
+        </p:spPr>
+        <p:txBody>
+          <a:bodyPr wrap="square" lIns="0" tIns="0" rIns="0" bIns="0" rtlCol="0" anchor="t"/>
           <a:lstStyle/>
           <a:p>
             <a:pPr algn="ctr" indent="0" marL="0">
@@ -13588,17 +13584,17 @@
         </p:nvSpPr>
         <p:spPr>
           <a:xfrm>
-            <a:off x="3030870" y="4590288"/>
-            <a:ext cx="1604406" cy="713232"/>
-          </a:xfrm>
-          <a:prstGeom prst="rect">
-            <a:avLst/>
-          </a:prstGeom>
-          <a:noFill/>
-          <a:ln/>
-        </p:spPr>
-        <p:txBody>
-          <a:bodyPr wrap="square" lIns="0" tIns="0" rIns="0" bIns="0" rtlCol="0" anchor="ctr"/>
+            <a:off x="2979664" y="4864608"/>
+            <a:ext cx="1699504" cy="841248"/>
+          </a:xfrm>
+          <a:prstGeom prst="rect">
+            <a:avLst/>
+          </a:prstGeom>
+          <a:noFill/>
+          <a:ln/>
+        </p:spPr>
+        <p:txBody>
+          <a:bodyPr wrap="square" lIns="0" tIns="0" rIns="0" bIns="0" rtlCol="0" anchor="t"/>
           <a:lstStyle/>
           <a:p>
             <a:pPr algn="ctr" indent="0" marL="0">
@@ -13630,12 +13626,12 @@
         </p:nvSpPr>
         <p:spPr>
           <a:xfrm>
-            <a:off x="5092476" y="2286000"/>
-            <a:ext cx="2006742" cy="3127248"/>
+            <a:off x="5099792" y="2231136"/>
+            <a:ext cx="1992112" cy="3639312"/>
           </a:xfrm>
           <a:prstGeom prst="roundRect">
             <a:avLst>
-              <a:gd name="adj" fmla="val 2734"/>
+              <a:gd name="adj" fmla="val 2754"/>
             </a:avLst>
           </a:prstGeom>
           <a:solidFill>
@@ -13659,8 +13655,8 @@
         </p:nvSpPr>
         <p:spPr>
           <a:xfrm>
-            <a:off x="5702656" y="2615184"/>
-            <a:ext cx="786384" cy="786384"/>
+            <a:off x="5501488" y="2560320"/>
+            <a:ext cx="1188720" cy="1188720"/>
           </a:xfrm>
           <a:prstGeom prst="roundRect">
             <a:avLst>
@@ -13681,8 +13677,8 @@
         </p:nvSpPr>
         <p:spPr>
           <a:xfrm>
-            <a:off x="5702656" y="2615184"/>
-            <a:ext cx="786384" cy="786384"/>
+            <a:off x="5501488" y="2560320"/>
+            <a:ext cx="1188720" cy="1188720"/>
           </a:xfrm>
           <a:prstGeom prst="rect">
             <a:avLst/>
@@ -13698,7 +13694,7 @@
               <a:buNone/>
             </a:pPr>
             <a:r>
-              <a:rPr lang="en-US" sz="2200" b="1" dirty="0">
+              <a:rPr lang="en-US" sz="3000" b="1" dirty="0">
                 <a:solidFill>
                   <a:srgbClr val="FFFFFF"/>
                 </a:solidFill>
@@ -13706,9 +13702,9 @@
                 <a:ea typeface="Times New Roman" pitchFamily="34" charset="-122"/>
                 <a:cs typeface="Times New Roman" pitchFamily="34" charset="-120"/>
               </a:rPr>
-              <a:t>VD</a:t>
-            </a:r>
-            <a:endParaRPr lang="en-US" sz="2200" dirty="0"/>
+              <a:t>NK</a:t>
+            </a:r>
+            <a:endParaRPr lang="en-US" sz="3000" dirty="0"/>
           </a:p>
         </p:txBody>
       </p:sp>
@@ -13720,8 +13716,8 @@
         </p:nvSpPr>
         <p:spPr>
           <a:xfrm>
-            <a:off x="5275356" y="3602736"/>
-            <a:ext cx="1640982" cy="512064"/>
+            <a:off x="5246096" y="3950208"/>
+            <a:ext cx="1699504" cy="310896"/>
           </a:xfrm>
           <a:prstGeom prst="rect">
             <a:avLst/>
@@ -13734,9 +13730,6 @@
           <a:lstStyle/>
           <a:p>
             <a:pPr algn="ctr" indent="0" marL="0">
-              <a:lnSpc>
-                <a:spcPct val="100000"/>
-              </a:lnSpc>
               <a:buNone/>
             </a:pPr>
             <a:r>
@@ -13748,7 +13741,7 @@
                 <a:ea typeface="Times New Roman" pitchFamily="34" charset="-122"/>
                 <a:cs typeface="Times New Roman" pitchFamily="34" charset="-120"/>
               </a:rPr>
-              <a:t>Vineeth Devadiga</a:t>
+              <a:t>Nilesh Kamble</a:t>
             </a:r>
             <a:endParaRPr lang="en-US" sz="1500" dirty="0"/>
           </a:p>
@@ -13762,17 +13755,17 @@
         </p:nvSpPr>
         <p:spPr>
           <a:xfrm>
-            <a:off x="5257068" y="4114800"/>
-            <a:ext cx="1677558" cy="420624"/>
-          </a:xfrm>
-          <a:prstGeom prst="rect">
-            <a:avLst/>
-          </a:prstGeom>
-          <a:noFill/>
-          <a:ln/>
-        </p:spPr>
-        <p:txBody>
-          <a:bodyPr wrap="square" lIns="0" tIns="0" rIns="0" bIns="0" rtlCol="0" anchor="ctr"/>
+            <a:off x="5227808" y="4315968"/>
+            <a:ext cx="1736080" cy="457200"/>
+          </a:xfrm>
+          <a:prstGeom prst="rect">
+            <a:avLst/>
+          </a:prstGeom>
+          <a:noFill/>
+          <a:ln/>
+        </p:spPr>
+        <p:txBody>
+          <a:bodyPr wrap="square" lIns="0" tIns="0" rIns="0" bIns="0" rtlCol="0" anchor="t"/>
           <a:lstStyle/>
           <a:p>
             <a:pPr algn="ctr" indent="0" marL="0">
@@ -13804,17 +13797,17 @@
         </p:nvSpPr>
         <p:spPr>
           <a:xfrm>
-            <a:off x="5293644" y="4590288"/>
-            <a:ext cx="1604406" cy="713232"/>
-          </a:xfrm>
-          <a:prstGeom prst="rect">
-            <a:avLst/>
-          </a:prstGeom>
-          <a:noFill/>
-          <a:ln/>
-        </p:spPr>
-        <p:txBody>
-          <a:bodyPr wrap="square" lIns="0" tIns="0" rIns="0" bIns="0" rtlCol="0" anchor="ctr"/>
+            <a:off x="5246096" y="4864608"/>
+            <a:ext cx="1699504" cy="841248"/>
+          </a:xfrm>
+          <a:prstGeom prst="rect">
+            <a:avLst/>
+          </a:prstGeom>
+          <a:noFill/>
+          <a:ln/>
+        </p:spPr>
+        <p:txBody>
+          <a:bodyPr wrap="square" lIns="0" tIns="0" rIns="0" bIns="0" rtlCol="0" anchor="t"/>
           <a:lstStyle/>
           <a:p>
             <a:pPr algn="ctr" indent="0" marL="0">
@@ -13846,12 +13839,12 @@
         </p:nvSpPr>
         <p:spPr>
           <a:xfrm>
-            <a:off x="7355251" y="2286000"/>
-            <a:ext cx="2006742" cy="3127248"/>
+            <a:off x="7366224" y="2231136"/>
+            <a:ext cx="1992112" cy="3639312"/>
           </a:xfrm>
           <a:prstGeom prst="roundRect">
             <a:avLst>
-              <a:gd name="adj" fmla="val 2734"/>
+              <a:gd name="adj" fmla="val 2754"/>
             </a:avLst>
           </a:prstGeom>
           <a:solidFill>
@@ -13875,8 +13868,8 @@
         </p:nvSpPr>
         <p:spPr>
           <a:xfrm>
-            <a:off x="7965430" y="2615184"/>
-            <a:ext cx="786384" cy="786384"/>
+            <a:off x="7767919" y="2560320"/>
+            <a:ext cx="1188720" cy="1188720"/>
           </a:xfrm>
           <a:prstGeom prst="roundRect">
             <a:avLst>
@@ -13897,8 +13890,8 @@
         </p:nvSpPr>
         <p:spPr>
           <a:xfrm>
-            <a:off x="7965430" y="2615184"/>
-            <a:ext cx="786384" cy="786384"/>
+            <a:off x="7767919" y="2560320"/>
+            <a:ext cx="1188720" cy="1188720"/>
           </a:xfrm>
           <a:prstGeom prst="rect">
             <a:avLst/>
@@ -13914,7 +13907,7 @@
               <a:buNone/>
             </a:pPr>
             <a:r>
-              <a:rPr lang="en-US" sz="2200" b="1" dirty="0">
+              <a:rPr lang="en-US" sz="3000" b="1" dirty="0">
                 <a:solidFill>
                   <a:srgbClr val="FFFFFF"/>
                 </a:solidFill>
@@ -13922,9 +13915,9 @@
                 <a:ea typeface="Times New Roman" pitchFamily="34" charset="-122"/>
                 <a:cs typeface="Times New Roman" pitchFamily="34" charset="-120"/>
               </a:rPr>
-              <a:t>AK</a:t>
-            </a:r>
-            <a:endParaRPr lang="en-US" sz="2200" dirty="0"/>
+              <a:t>SR</a:t>
+            </a:r>
+            <a:endParaRPr lang="en-US" sz="3000" dirty="0"/>
           </a:p>
         </p:txBody>
       </p:sp>
@@ -13936,8 +13929,8 @@
         </p:nvSpPr>
         <p:spPr>
           <a:xfrm>
-            <a:off x="7538131" y="3602736"/>
-            <a:ext cx="1640982" cy="512064"/>
+            <a:off x="7512528" y="3950208"/>
+            <a:ext cx="1699504" cy="310896"/>
           </a:xfrm>
           <a:prstGeom prst="rect">
             <a:avLst/>
@@ -13950,9 +13943,6 @@
           <a:lstStyle/>
           <a:p>
             <a:pPr algn="ctr" indent="0" marL="0">
-              <a:lnSpc>
-                <a:spcPct val="100000"/>
-              </a:lnSpc>
               <a:buNone/>
             </a:pPr>
             <a:r>
@@ -13964,7 +13954,7 @@
                 <a:ea typeface="Times New Roman" pitchFamily="34" charset="-122"/>
                 <a:cs typeface="Times New Roman" pitchFamily="34" charset="-120"/>
               </a:rPr>
-              <a:t>Atharva Kadam</a:t>
+              <a:t>Sumithra Raju</a:t>
             </a:r>
             <a:endParaRPr lang="en-US" sz="1500" dirty="0"/>
           </a:p>
@@ -13978,17 +13968,17 @@
         </p:nvSpPr>
         <p:spPr>
           <a:xfrm>
-            <a:off x="7519843" y="4114800"/>
-            <a:ext cx="1677558" cy="420624"/>
-          </a:xfrm>
-          <a:prstGeom prst="rect">
-            <a:avLst/>
-          </a:prstGeom>
-          <a:noFill/>
-          <a:ln/>
-        </p:spPr>
-        <p:txBody>
-          <a:bodyPr wrap="square" lIns="0" tIns="0" rIns="0" bIns="0" rtlCol="0" anchor="ctr"/>
+            <a:off x="7494240" y="4315968"/>
+            <a:ext cx="1736080" cy="457200"/>
+          </a:xfrm>
+          <a:prstGeom prst="rect">
+            <a:avLst/>
+          </a:prstGeom>
+          <a:noFill/>
+          <a:ln/>
+        </p:spPr>
+        <p:txBody>
+          <a:bodyPr wrap="square" lIns="0" tIns="0" rIns="0" bIns="0" rtlCol="0" anchor="t"/>
           <a:lstStyle/>
           <a:p>
             <a:pPr algn="ctr" indent="0" marL="0">
@@ -14020,17 +14010,17 @@
         </p:nvSpPr>
         <p:spPr>
           <a:xfrm>
-            <a:off x="7556419" y="4590288"/>
-            <a:ext cx="1604406" cy="713232"/>
-          </a:xfrm>
-          <a:prstGeom prst="rect">
-            <a:avLst/>
-          </a:prstGeom>
-          <a:noFill/>
-          <a:ln/>
-        </p:spPr>
-        <p:txBody>
-          <a:bodyPr wrap="square" lIns="0" tIns="0" rIns="0" bIns="0" rtlCol="0" anchor="ctr"/>
+            <a:off x="7512528" y="4864608"/>
+            <a:ext cx="1699504" cy="841248"/>
+          </a:xfrm>
+          <a:prstGeom prst="rect">
+            <a:avLst/>
+          </a:prstGeom>
+          <a:noFill/>
+          <a:ln/>
+        </p:spPr>
+        <p:txBody>
+          <a:bodyPr wrap="square" lIns="0" tIns="0" rIns="0" bIns="0" rtlCol="0" anchor="t"/>
           <a:lstStyle/>
           <a:p>
             <a:pPr algn="ctr" indent="0" marL="0">
@@ -14062,12 +14052,12 @@
         </p:nvSpPr>
         <p:spPr>
           <a:xfrm>
-            <a:off x="9618025" y="2286000"/>
-            <a:ext cx="2006742" cy="3127248"/>
+            <a:off x="9632655" y="2231136"/>
+            <a:ext cx="1992112" cy="3639312"/>
           </a:xfrm>
           <a:prstGeom prst="roundRect">
             <a:avLst>
-              <a:gd name="adj" fmla="val 2734"/>
+              <a:gd name="adj" fmla="val 2754"/>
             </a:avLst>
           </a:prstGeom>
           <a:solidFill>
@@ -14091,8 +14081,8 @@
         </p:nvSpPr>
         <p:spPr>
           <a:xfrm>
-            <a:off x="10228204" y="2615184"/>
-            <a:ext cx="786384" cy="786384"/>
+            <a:off x="10034351" y="2560320"/>
+            <a:ext cx="1188720" cy="1188720"/>
           </a:xfrm>
           <a:prstGeom prst="roundRect">
             <a:avLst>
@@ -14113,8 +14103,8 @@
         </p:nvSpPr>
         <p:spPr>
           <a:xfrm>
-            <a:off x="10228204" y="2615184"/>
-            <a:ext cx="786384" cy="786384"/>
+            <a:off x="10034351" y="2560320"/>
+            <a:ext cx="1188720" cy="1188720"/>
           </a:xfrm>
           <a:prstGeom prst="rect">
             <a:avLst/>
@@ -14130,7 +14120,7 @@
               <a:buNone/>
             </a:pPr>
             <a:r>
-              <a:rPr lang="en-US" sz="2200" b="1" dirty="0">
+              <a:rPr lang="en-US" sz="3000" b="1" dirty="0">
                 <a:solidFill>
                   <a:srgbClr val="FFFFFF"/>
                 </a:solidFill>
@@ -14138,9 +14128,9 @@
                 <a:ea typeface="Times New Roman" pitchFamily="34" charset="-122"/>
                 <a:cs typeface="Times New Roman" pitchFamily="34" charset="-120"/>
               </a:rPr>
-              <a:t>NK</a:t>
-            </a:r>
-            <a:endParaRPr lang="en-US" sz="2200" dirty="0"/>
+              <a:t>VD</a:t>
+            </a:r>
+            <a:endParaRPr lang="en-US" sz="3000" dirty="0"/>
           </a:p>
         </p:txBody>
       </p:sp>
@@ -14152,8 +14142,8 @@
         </p:nvSpPr>
         <p:spPr>
           <a:xfrm>
-            <a:off x="9800905" y="3602736"/>
-            <a:ext cx="1640982" cy="512064"/>
+            <a:off x="9778959" y="3950208"/>
+            <a:ext cx="1699504" cy="310896"/>
           </a:xfrm>
           <a:prstGeom prst="rect">
             <a:avLst/>
@@ -14166,9 +14156,6 @@
           <a:lstStyle/>
           <a:p>
             <a:pPr algn="ctr" indent="0" marL="0">
-              <a:lnSpc>
-                <a:spcPct val="100000"/>
-              </a:lnSpc>
               <a:buNone/>
             </a:pPr>
             <a:r>
@@ -14180,7 +14167,7 @@
                 <a:ea typeface="Times New Roman" pitchFamily="34" charset="-122"/>
                 <a:cs typeface="Times New Roman" pitchFamily="34" charset="-120"/>
               </a:rPr>
-              <a:t>Nilesh Kamble</a:t>
+              <a:t>Vineeth Devadiga</a:t>
             </a:r>
             <a:endParaRPr lang="en-US" sz="1500" dirty="0"/>
           </a:p>
@@ -14194,17 +14181,17 @@
         </p:nvSpPr>
         <p:spPr>
           <a:xfrm>
-            <a:off x="9782617" y="4114800"/>
-            <a:ext cx="1677558" cy="420624"/>
-          </a:xfrm>
-          <a:prstGeom prst="rect">
-            <a:avLst/>
-          </a:prstGeom>
-          <a:noFill/>
-          <a:ln/>
-        </p:spPr>
-        <p:txBody>
-          <a:bodyPr wrap="square" lIns="0" tIns="0" rIns="0" bIns="0" rtlCol="0" anchor="ctr"/>
+            <a:off x="9760671" y="4315968"/>
+            <a:ext cx="1736080" cy="457200"/>
+          </a:xfrm>
+          <a:prstGeom prst="rect">
+            <a:avLst/>
+          </a:prstGeom>
+          <a:noFill/>
+          <a:ln/>
+        </p:spPr>
+        <p:txBody>
+          <a:bodyPr wrap="square" lIns="0" tIns="0" rIns="0" bIns="0" rtlCol="0" anchor="t"/>
           <a:lstStyle/>
           <a:p>
             <a:pPr algn="ctr" indent="0" marL="0">
@@ -14236,17 +14223,17 @@
         </p:nvSpPr>
         <p:spPr>
           <a:xfrm>
-            <a:off x="9819193" y="4590288"/>
-            <a:ext cx="1604406" cy="713232"/>
-          </a:xfrm>
-          <a:prstGeom prst="rect">
-            <a:avLst/>
-          </a:prstGeom>
-          <a:noFill/>
-          <a:ln/>
-        </p:spPr>
-        <p:txBody>
-          <a:bodyPr wrap="square" lIns="0" tIns="0" rIns="0" bIns="0" rtlCol="0" anchor="ctr"/>
+            <a:off x="9778959" y="4864608"/>
+            <a:ext cx="1699504" cy="841248"/>
+          </a:xfrm>
+          <a:prstGeom prst="rect">
+            <a:avLst/>
+          </a:prstGeom>
+          <a:noFill/>
+          <a:ln/>
+        </p:spPr>
+        <p:txBody>
+          <a:bodyPr wrap="square" lIns="0" tIns="0" rIns="0" bIns="0" rtlCol="0" anchor="t"/>
           <a:lstStyle/>
           <a:p>
             <a:pPr algn="ctr" indent="0" marL="0">

</xml_diff>